<commit_message>
feat: update front cover from revised PPTX across website and PDF
</commit_message>
<xml_diff>
--- a/Data2thesisBookCover.pptx
+++ b/Data2thesisBookCover.pptx
@@ -244,7 +244,7 @@
           <a:p>
             <a:fld id="{8A423862-3F52-459D-BB97-400A2FF529BA}" type="datetimeFigureOut">
               <a:rPr lang="en-US" smtClean="0"/>
-              <a:t>2026-09-27</a:t>
+              <a:t>2026-09-30</a:t>
             </a:fld>
             <a:endParaRPr lang="en-US"/>
           </a:p>
@@ -414,7 +414,7 @@
           <a:p>
             <a:fld id="{8A423862-3F52-459D-BB97-400A2FF529BA}" type="datetimeFigureOut">
               <a:rPr lang="en-US" smtClean="0"/>
-              <a:t>2026-09-27</a:t>
+              <a:t>2026-09-30</a:t>
             </a:fld>
             <a:endParaRPr lang="en-US"/>
           </a:p>
@@ -594,7 +594,7 @@
           <a:p>
             <a:fld id="{8A423862-3F52-459D-BB97-400A2FF529BA}" type="datetimeFigureOut">
               <a:rPr lang="en-US" smtClean="0"/>
-              <a:t>2026-09-27</a:t>
+              <a:t>2026-09-30</a:t>
             </a:fld>
             <a:endParaRPr lang="en-US"/>
           </a:p>
@@ -764,7 +764,7 @@
           <a:p>
             <a:fld id="{8A423862-3F52-459D-BB97-400A2FF529BA}" type="datetimeFigureOut">
               <a:rPr lang="en-US" smtClean="0"/>
-              <a:t>2026-09-27</a:t>
+              <a:t>2026-09-30</a:t>
             </a:fld>
             <a:endParaRPr lang="en-US"/>
           </a:p>
@@ -1010,7 +1010,7 @@
           <a:p>
             <a:fld id="{8A423862-3F52-459D-BB97-400A2FF529BA}" type="datetimeFigureOut">
               <a:rPr lang="en-US" smtClean="0"/>
-              <a:t>2026-09-27</a:t>
+              <a:t>2026-09-30</a:t>
             </a:fld>
             <a:endParaRPr lang="en-US"/>
           </a:p>
@@ -1242,7 +1242,7 @@
           <a:p>
             <a:fld id="{8A423862-3F52-459D-BB97-400A2FF529BA}" type="datetimeFigureOut">
               <a:rPr lang="en-US" smtClean="0"/>
-              <a:t>2026-09-27</a:t>
+              <a:t>2026-09-30</a:t>
             </a:fld>
             <a:endParaRPr lang="en-US"/>
           </a:p>
@@ -1609,7 +1609,7 @@
           <a:p>
             <a:fld id="{8A423862-3F52-459D-BB97-400A2FF529BA}" type="datetimeFigureOut">
               <a:rPr lang="en-US" smtClean="0"/>
-              <a:t>2026-09-27</a:t>
+              <a:t>2026-09-30</a:t>
             </a:fld>
             <a:endParaRPr lang="en-US"/>
           </a:p>
@@ -1727,7 +1727,7 @@
           <a:p>
             <a:fld id="{8A423862-3F52-459D-BB97-400A2FF529BA}" type="datetimeFigureOut">
               <a:rPr lang="en-US" smtClean="0"/>
-              <a:t>2026-09-27</a:t>
+              <a:t>2026-09-30</a:t>
             </a:fld>
             <a:endParaRPr lang="en-US"/>
           </a:p>
@@ -1822,7 +1822,7 @@
           <a:p>
             <a:fld id="{8A423862-3F52-459D-BB97-400A2FF529BA}" type="datetimeFigureOut">
               <a:rPr lang="en-US" smtClean="0"/>
-              <a:t>2026-09-27</a:t>
+              <a:t>2026-09-30</a:t>
             </a:fld>
             <a:endParaRPr lang="en-US"/>
           </a:p>
@@ -2099,7 +2099,7 @@
           <a:p>
             <a:fld id="{8A423862-3F52-459D-BB97-400A2FF529BA}" type="datetimeFigureOut">
               <a:rPr lang="en-US" smtClean="0"/>
-              <a:t>2026-09-27</a:t>
+              <a:t>2026-09-30</a:t>
             </a:fld>
             <a:endParaRPr lang="en-US"/>
           </a:p>
@@ -2356,7 +2356,7 @@
           <a:p>
             <a:fld id="{8A423862-3F52-459D-BB97-400A2FF529BA}" type="datetimeFigureOut">
               <a:rPr lang="en-US" smtClean="0"/>
-              <a:t>2026-09-27</a:t>
+              <a:t>2026-09-30</a:t>
             </a:fld>
             <a:endParaRPr lang="en-US"/>
           </a:p>
@@ -2569,7 +2569,7 @@
           <a:p>
             <a:fld id="{8A423862-3F52-459D-BB97-400A2FF529BA}" type="datetimeFigureOut">
               <a:rPr lang="en-US" smtClean="0"/>
-              <a:t>2026-09-27</a:t>
+              <a:t>2026-09-30</a:t>
             </a:fld>
             <a:endParaRPr lang="en-US"/>
           </a:p>
@@ -3193,8 +3193,45 @@
                 <a:ea typeface="ADLaM Display" panose="020F0502020204030204" pitchFamily="2" charset="0"/>
                 <a:cs typeface="Mongolian Baiti" panose="03000500000000000000" pitchFamily="66" charset="0"/>
               </a:rPr>
-              <a:t>Using R for Non-technical</a:t>
-            </a:r>
+              <a:t>Using R </a:t>
+            </a:r>
+            <a:r>
+              <a:rPr lang="en-US" sz="2000" b="1">
+                <a:ln/>
+                <a:solidFill>
+                  <a:srgbClr val="1E272E"/>
+                </a:solidFill>
+                <a:effectLst>
+                  <a:outerShdw blurRad="38100" dist="19050" dir="2700000" algn="tl" rotWithShape="0">
+                    <a:schemeClr val="dk1">
+                      <a:lumMod val="50000"/>
+                      <a:alpha val="40000"/>
+                    </a:schemeClr>
+                  </a:outerShdw>
+                </a:effectLst>
+                <a:latin typeface="Mongolian Baiti" panose="03000500000000000000" pitchFamily="66" charset="0"/>
+                <a:ea typeface="ADLaM Display" panose="020F0502020204030204" pitchFamily="2" charset="0"/>
+                <a:cs typeface="Mongolian Baiti" panose="03000500000000000000" pitchFamily="66" charset="0"/>
+              </a:rPr>
+              <a:t>for Non-Technical</a:t>
+            </a:r>
+            <a:endParaRPr lang="en-US" sz="2000" b="1" dirty="0">
+              <a:ln/>
+              <a:solidFill>
+                <a:srgbClr val="1E272E"/>
+              </a:solidFill>
+              <a:effectLst>
+                <a:outerShdw blurRad="38100" dist="19050" dir="2700000" algn="tl" rotWithShape="0">
+                  <a:schemeClr val="dk1">
+                    <a:lumMod val="50000"/>
+                    <a:alpha val="40000"/>
+                  </a:schemeClr>
+                </a:outerShdw>
+              </a:effectLst>
+              <a:latin typeface="Mongolian Baiti" panose="03000500000000000000" pitchFamily="66" charset="0"/>
+              <a:ea typeface="ADLaM Display" panose="020F0502020204030204" pitchFamily="2" charset="0"/>
+              <a:cs typeface="Mongolian Baiti" panose="03000500000000000000" pitchFamily="66" charset="0"/>
+            </a:endParaRPr>
           </a:p>
         </p:txBody>
       </p:sp>
@@ -3479,8 +3516,8 @@
         </p:blipFill>
         <p:spPr>
           <a:xfrm>
-            <a:off x="1824863" y="2768239"/>
-            <a:ext cx="3208274" cy="4008913"/>
+            <a:off x="1458636" y="2383997"/>
+            <a:ext cx="3882004" cy="4850776"/>
           </a:xfrm>
           <a:prstGeom prst="rect">
             <a:avLst/>

</xml_diff>

<commit_message>
chore: update front and back book covers for website and PDF
</commit_message>
<xml_diff>
--- a/Data2thesisBookCover.pptx
+++ b/Data2thesisBookCover.pptx
@@ -244,7 +244,7 @@
           <a:p>
             <a:fld id="{8A423862-3F52-459D-BB97-400A2FF529BA}" type="datetimeFigureOut">
               <a:rPr lang="en-US" smtClean="0"/>
-              <a:t>2026-09-30</a:t>
+              <a:t>2026-10-23</a:t>
             </a:fld>
             <a:endParaRPr lang="en-US"/>
           </a:p>
@@ -414,7 +414,7 @@
           <a:p>
             <a:fld id="{8A423862-3F52-459D-BB97-400A2FF529BA}" type="datetimeFigureOut">
               <a:rPr lang="en-US" smtClean="0"/>
-              <a:t>2026-09-30</a:t>
+              <a:t>2026-10-23</a:t>
             </a:fld>
             <a:endParaRPr lang="en-US"/>
           </a:p>
@@ -594,7 +594,7 @@
           <a:p>
             <a:fld id="{8A423862-3F52-459D-BB97-400A2FF529BA}" type="datetimeFigureOut">
               <a:rPr lang="en-US" smtClean="0"/>
-              <a:t>2026-09-30</a:t>
+              <a:t>2026-10-23</a:t>
             </a:fld>
             <a:endParaRPr lang="en-US"/>
           </a:p>
@@ -764,7 +764,7 @@
           <a:p>
             <a:fld id="{8A423862-3F52-459D-BB97-400A2FF529BA}" type="datetimeFigureOut">
               <a:rPr lang="en-US" smtClean="0"/>
-              <a:t>2026-09-30</a:t>
+              <a:t>2026-10-23</a:t>
             </a:fld>
             <a:endParaRPr lang="en-US"/>
           </a:p>
@@ -1010,7 +1010,7 @@
           <a:p>
             <a:fld id="{8A423862-3F52-459D-BB97-400A2FF529BA}" type="datetimeFigureOut">
               <a:rPr lang="en-US" smtClean="0"/>
-              <a:t>2026-09-30</a:t>
+              <a:t>2026-10-23</a:t>
             </a:fld>
             <a:endParaRPr lang="en-US"/>
           </a:p>
@@ -1242,7 +1242,7 @@
           <a:p>
             <a:fld id="{8A423862-3F52-459D-BB97-400A2FF529BA}" type="datetimeFigureOut">
               <a:rPr lang="en-US" smtClean="0"/>
-              <a:t>2026-09-30</a:t>
+              <a:t>2026-10-23</a:t>
             </a:fld>
             <a:endParaRPr lang="en-US"/>
           </a:p>
@@ -1609,7 +1609,7 @@
           <a:p>
             <a:fld id="{8A423862-3F52-459D-BB97-400A2FF529BA}" type="datetimeFigureOut">
               <a:rPr lang="en-US" smtClean="0"/>
-              <a:t>2026-09-30</a:t>
+              <a:t>2026-10-23</a:t>
             </a:fld>
             <a:endParaRPr lang="en-US"/>
           </a:p>
@@ -1727,7 +1727,7 @@
           <a:p>
             <a:fld id="{8A423862-3F52-459D-BB97-400A2FF529BA}" type="datetimeFigureOut">
               <a:rPr lang="en-US" smtClean="0"/>
-              <a:t>2026-09-30</a:t>
+              <a:t>2026-10-23</a:t>
             </a:fld>
             <a:endParaRPr lang="en-US"/>
           </a:p>
@@ -1822,7 +1822,7 @@
           <a:p>
             <a:fld id="{8A423862-3F52-459D-BB97-400A2FF529BA}" type="datetimeFigureOut">
               <a:rPr lang="en-US" smtClean="0"/>
-              <a:t>2026-09-30</a:t>
+              <a:t>2026-10-23</a:t>
             </a:fld>
             <a:endParaRPr lang="en-US"/>
           </a:p>
@@ -2099,7 +2099,7 @@
           <a:p>
             <a:fld id="{8A423862-3F52-459D-BB97-400A2FF529BA}" type="datetimeFigureOut">
               <a:rPr lang="en-US" smtClean="0"/>
-              <a:t>2026-09-30</a:t>
+              <a:t>2026-10-23</a:t>
             </a:fld>
             <a:endParaRPr lang="en-US"/>
           </a:p>
@@ -2356,7 +2356,7 @@
           <a:p>
             <a:fld id="{8A423862-3F52-459D-BB97-400A2FF529BA}" type="datetimeFigureOut">
               <a:rPr lang="en-US" smtClean="0"/>
-              <a:t>2026-09-30</a:t>
+              <a:t>2026-10-23</a:t>
             </a:fld>
             <a:endParaRPr lang="en-US"/>
           </a:p>
@@ -2569,7 +2569,7 @@
           <a:p>
             <a:fld id="{8A423862-3F52-459D-BB97-400A2FF529BA}" type="datetimeFigureOut">
               <a:rPr lang="en-US" smtClean="0"/>
-              <a:t>2026-09-30</a:t>
+              <a:t>2026-10-23</a:t>
             </a:fld>
             <a:endParaRPr lang="en-US"/>
           </a:p>
@@ -2976,10 +2976,10 @@
       </p:grpSpPr>
       <p:pic>
         <p:nvPicPr>
-          <p:cNvPr id="5" name="Picture 4">
+          <p:cNvPr id="3" name="Picture 2">
             <a:extLst>
               <a:ext uri="{FF2B5EF4-FFF2-40B4-BE49-F238E27FC236}">
-                <a16:creationId xmlns:a16="http://schemas.microsoft.com/office/drawing/2014/main" id="{8B6D0C78-5C07-A24C-CB49-846D76F413A3}"/>
+                <a16:creationId xmlns:a16="http://schemas.microsoft.com/office/drawing/2014/main" id="{394891D6-3A06-A485-5369-70B257928EB0}"/>
               </a:ext>
             </a:extLst>
           </p:cNvPr>
@@ -2990,6 +2990,7 @@
         </p:nvPicPr>
         <p:blipFill>
           <a:blip r:embed="rId2"/>
+          <a:srcRect b="11166"/>
           <a:stretch>
             <a:fillRect/>
           </a:stretch>
@@ -2997,7 +2998,7 @@
         <p:spPr>
           <a:xfrm>
             <a:off x="0" y="-50334"/>
-            <a:ext cx="6858000" cy="9179859"/>
+            <a:ext cx="6858000" cy="9194334"/>
           </a:xfrm>
           <a:prstGeom prst="rect">
             <a:avLst/>
@@ -3448,7 +3449,7 @@
                 <a:latin typeface="Bookman Old Style" panose="02050604050505020204" pitchFamily="18" charset="0"/>
                 <a:cs typeface="Posterama" panose="020B0504020200020000" pitchFamily="34" charset="0"/>
               </a:rPr>
-              <a:t>by Polla Fattah</a:t>
+              <a:t>by Polla Fattah </a:t>
             </a:r>
           </a:p>
           <a:p>
@@ -3489,7 +3490,7 @@
                 <a:latin typeface="Bookman Old Style" panose="02050604050505020204" pitchFamily="18" charset="0"/>
                 <a:cs typeface="Posterama" panose="020B0504020200020000" pitchFamily="34" charset="0"/>
               </a:rPr>
-              <a:t>and Collection of LLMs</a:t>
+              <a:t>and an Ensemble of LLMs</a:t>
             </a:r>
           </a:p>
         </p:txBody>

</xml_diff>